<commit_message>
Demo script; project decks updated with the newest features and numbers
Co-Authored-By: Claude Opus 5.5 <noreply@anthropic.com>
</commit_message>
<xml_diff>
--- a/flyer/PITCH DECK CAPSTONE.pptx
+++ b/flyer/PITCH DECK CAPSTONE.pptx
@@ -701,7 +701,7 @@
           <a:p>
             <a:r>
               <a:rPr lang="en-US" dirty="0"/>
-              <a:t>Ini semua fitur aplikasi dalam satu slide: dasbor aktivitas terdekat, jelajahi dan cari, aktivitas saya, berbagi, komentar, pesan pribadi, profil komunitas dan teman, notifikasi, serta tiket bantuan.</a:t>
+              <a:t>Ini semua fitur aplikasi dalam satu slide: dasbor aktivitas terdekat, jelajahi dan cari, aktivitas saya dengan check-in dan penilaian, berbagi, komentar, pesan pribadi, profil komunitas, teman dan grup, notifikasi lewat email dan push di ponsel, serta tiket bantuan.</a:t>
             </a:r>
             <a:endParaRPr lang="en-US" dirty="0"/>
           </a:p>
@@ -1229,7 +1229,7 @@
           <a:p>
             <a:r>
               <a:rPr lang="en-US" dirty="0"/>
-              <a:t>Data disimpan di lima tempat. Yang utama adalah database Postgres di Supabase dengan 31 tabel, semuanya dilindungi row-level security. Supabase Auth menyimpan akun dan sesi. Supabase Storage menyimpan gambar banner dan lampiran keluhan. Perangkat pengguna menyimpan pilihan bahasa dan lokasi; GPS langsung tidak pernah keluar dari perangkat. Dan Vercel menyimpan beberapa kunci rahasia server.</a:t>
+              <a:t>Data disimpan di lima tempat. Yang utama adalah database Postgres di Supabase dengan 41 tabel, semuanya dilindungi row-level security. Supabase Auth menyimpan akun dan sesi. Supabase Storage menyimpan gambar banner dan lampiran keluhan. Perangkat pengguna menyimpan pilihan bahasa dan lokasi; GPS langsung tidak pernah keluar dari perangkat. Dan Vercel menyimpan beberapa kunci rahasia server.</a:t>
             </a:r>
             <a:endParaRPr lang="en-US" dirty="0"/>
           </a:p>
@@ -1317,7 +1317,7 @@
           <a:p>
             <a:r>
               <a:rPr lang="en-US" dirty="0"/>
-              <a:t>Ke-31 tabel terbagi dalam lima kelompok: pengguna dan pengaturannya, aktivitas dan peserta, pesan pribadi, bantuan dan notifikasi, serta catatan admin dan keamanan seperti log audit. View seperti my_profile hanya menampilkan data yang boleh dilihat tiap pengguna.</a:t>
+              <a:t>Ke-41 tabel terbagi dalam lima kelompok: pengguna dan pengaturannya, aktivitas beserta peserta, daftar tunggu, check-in, dan penilaian, grup dan pesan pribadi, bantuan dan notifikasi, serta catatan admin dan keamanan seperti log audit. View seperti my_profile hanya menampilkan data yang boleh dilihat tiap pengguna.</a:t>
             </a:r>
             <a:endParaRPr lang="en-US" dirty="0"/>
           </a:p>
@@ -1405,7 +1405,7 @@
           <a:p>
             <a:r>
               <a:rPr lang="en-US" dirty="0"/>
-              <a:t>Keamanan ditegakkan di database. Setiap tabel memakai row-level security, dan lebih dari 150 fungsi SQL mengecek peran pemanggilnya. GPS tidak pernah disimpan. PIN di-hash dengan bcrypt dan dikunci setelah gagal berulang kali. Anggota lain tidak bisa membaca data profil pribadi. Tindakan admin dicatat di log audit, dan anggota bisa melapor, memblokir, dan mengirim keluhan.</a:t>
+              <a:t>Keamanan ditegakkan di database. Setiap tabel memakai row-level security, dan lebih dari 190 fungsi SQL mengecek peran pemanggilnya. GPS tidak pernah disimpan. PIN di-hash dengan bcrypt dan dikunci setelah gagal berulang kali. Anggota lain tidak bisa membaca data profil pribadi. Tindakan admin dicatat di log audit, dan anggota bisa melapor, memblokir, dan mengirim keluhan.</a:t>
             </a:r>
             <a:endParaRPr lang="en-US" dirty="0"/>
           </a:p>
@@ -1669,7 +1669,7 @@
           <a:p>
             <a:r>
               <a:rPr lang="en-US" dirty="0"/>
-              <a:t>Dalam angka: 45 layar, 51 komponen, sekitar 19.400 baris TypeScript dan 4.600 baris SQL, 31 tabel database yang semuanya dilindungi row-level security, dan lebih dari 1.400 teks antarmuka dalam bahasa Inggris dan Indonesia.</a:t>
+              <a:t>Dalam angka: 52 layar, 74 komponen, sekitar 25.600 baris TypeScript dengan 43 unit test, 5.900 baris SQL dalam 26 migrasi, 41 tabel database yang semuanya dilindungi row-level security, dan lebih dari 1.700 teks antarmuka dalam bahasa Inggris dan Indonesia.</a:t>
             </a:r>
             <a:endParaRPr lang="en-US" dirty="0"/>
           </a:p>
@@ -1757,7 +1757,7 @@
           <a:p>
             <a:r>
               <a:rPr lang="en-US" dirty="0"/>
-              <a:t>Perubahan terbaru: banner berbentuk apa pun kini tampil utuh, penyelenggara dan admin bisa membuat flyer dalam tiga ukuran, pembuatan aktivitas diperbaiki lewat migrasi database kecil, dan framework ditingkatkan demi keamanan.</a:t>
+              <a:t>Fitur terbaru: aktivitas yang penuh punya daftar tunggu yang maju otomatis, dan pengguna mendapat peringatan untuk aktivitas baru yang sesuai hobinya. Penyelenggara bisa mencatat kehadiran dengan kode QR, dan peserta menilai aktivitasnya setelah selesai. Pengingat dan permintaan penilaian dikirim lewat email dan push di ponsel. Penyelenggara juga mendapat alat praktis: duplikat, ubah seluruh seri mingguan, ekspor CSV, dan QR layar besar agar seisi ruangan bisa ikut langsung. Pindai kode ini untuk mencoba sekarang.</a:t>
             </a:r>
             <a:endParaRPr lang="en-US" dirty="0"/>
           </a:p>
@@ -1845,7 +1845,7 @@
           <a:p>
             <a:r>
               <a:rPr lang="en-US" dirty="0"/>
-              <a:t>Kami terbuka soal yang masih kurang: faktor masuk kedua yang lebih kuat, laporan terjadwal, menyembunyikan nomor penyelenggara di level database, penghapusan akun sepenuhnya, ekspor yang lebih besar, dan merapikan peringatan lint yang tersisa.</a:t>
+              <a:t>Kami terbuka soal yang masih kurang: faktor masuk kedua yang lebih kuat, laporan admin terjadwal, pembayaran di aplikasi, penghapusan akun sepenuhnya, ekspor yang lebih besar, serta chat grup dan album foto per aktivitas.</a:t>
             </a:r>
             <a:endParaRPr lang="en-US" dirty="0"/>
           </a:p>
@@ -5323,7 +5323,7 @@
                 <a:ea typeface="Arial" pitchFamily="34" charset="-122"/>
                 <a:cs typeface="Arial" pitchFamily="34" charset="-120"/>
               </a:rPr>
-              <a:t>Yang kamu selenggarakan dan yang kamu ikuti</a:t>
+              <a:t>Yang kamu selenggarakan dan ikuti, dengan check-in dan penilaian</a:t>
             </a:r>
             <a:endParaRPr lang="en-US" sz="1250" dirty="0"/>
           </a:p>
@@ -5955,7 +5955,7 @@
                 <a:ea typeface="Arial" pitchFamily="34" charset="-122"/>
                 <a:cs typeface="Arial" pitchFamily="34" charset="-120"/>
               </a:rPr>
-              <a:t>Profil publik, username, teman, tautan sosial</a:t>
+              <a:t>Profil, teman, grup, dan teman yang ikut</a:t>
             </a:r>
             <a:endParaRPr lang="en-US" sz="1250" dirty="0"/>
           </a:p>
@@ -6113,7 +6113,7 @@
                 <a:ea typeface="Arial" pitchFamily="34" charset="-122"/>
                 <a:cs typeface="Arial" pitchFamily="34" charset="-120"/>
               </a:rPr>
-              <a:t>Persetujuan, balasan, dan pembaruan, bisa diatur</a:t>
+              <a:t>Pengingat, peringatan, dan persetujuan, via email dan push</a:t>
             </a:r>
             <a:endParaRPr lang="en-US" sz="1250" dirty="0"/>
           </a:p>
@@ -10822,7 +10822,7 @@
                 <a:ea typeface="Arial" pitchFamily="34" charset="-122"/>
                 <a:cs typeface="Arial" pitchFamily="34" charset="-120"/>
               </a:rPr>
-              <a:t>31 tabel · 2 view</a:t>
+              <a:t>41 tabel · 2 view</a:t>
             </a:r>
             <a:endParaRPr lang="en-US" sz="1200" dirty="0"/>
           </a:p>
@@ -11649,7 +11649,7 @@
                 <a:ea typeface="Arial" pitchFamily="34" charset="-122"/>
                 <a:cs typeface="Arial" pitchFamily="34" charset="-120"/>
               </a:rPr>
-              <a:t>Service-role key dan kata sandi SMTP. Hanya di server, tidak dikirim ke browser atau ke GitHub.</a:t>
+              <a:t>Service-role key, kata sandi SMTP, dan kunci notifikasi push. Hanya di server, tidak dikirim ke browser atau ke GitHub.</a:t>
             </a:r>
             <a:endParaRPr lang="en-US" sz="1200" dirty="0"/>
           </a:p>
@@ -11759,7 +11759,7 @@
                 <a:ea typeface="Arial" pitchFamily="34" charset="-122"/>
                 <a:cs typeface="Arial" pitchFamily="34" charset="-120"/>
               </a:rPr>
-              <a:t>31 tabel dalam lima kelompok</a:t>
+              <a:t>41 tabel dalam lima kelompok</a:t>
             </a:r>
             <a:endParaRPr lang="en-US" sz="3400" dirty="0"/>
           </a:p>
@@ -12399,7 +12399,7 @@
                 <a:ea typeface="Arial" pitchFamily="34" charset="-122"/>
                 <a:cs typeface="Arial" pitchFamily="34" charset="-120"/>
               </a:rPr>
-              <a:t>5 tabel</a:t>
+              <a:t>9 tabel</a:t>
             </a:r>
             <a:endParaRPr lang="en-US" sz="1150" dirty="0"/>
           </a:p>
@@ -12482,6 +12482,86 @@
                 <a:cs typeface="Arial" pitchFamily="34" charset="-120"/>
               </a:rPr>
               <a:t>event_participants</a:t>
+            </a:r>
+            <a:endParaRPr lang="en-US" sz="1050" dirty="0"/>
+          </a:p>
+          <a:p>
+            <a:pPr indent="0" marL="0">
+              <a:spcAft>
+                <a:spcPts val="300"/>
+              </a:spcAft>
+              <a:buNone/>
+            </a:pPr>
+            <a:r>
+              <a:rPr lang="en-US" sz="1050" dirty="0">
+                <a:solidFill>
+                  <a:srgbClr val="44403C"/>
+                </a:solidFill>
+                <a:latin typeface="Arial" pitchFamily="34" charset="0"/>
+                <a:ea typeface="Arial" pitchFamily="34" charset="-122"/>
+                <a:cs typeface="Arial" pitchFamily="34" charset="-120"/>
+              </a:rPr>
+              <a:t>event_contacts</a:t>
+            </a:r>
+            <a:endParaRPr lang="en-US" sz="1050" dirty="0"/>
+          </a:p>
+          <a:p>
+            <a:pPr indent="0" marL="0">
+              <a:spcAft>
+                <a:spcPts val="300"/>
+              </a:spcAft>
+              <a:buNone/>
+            </a:pPr>
+            <a:r>
+              <a:rPr lang="en-US" sz="1050" dirty="0">
+                <a:solidFill>
+                  <a:srgbClr val="44403C"/>
+                </a:solidFill>
+                <a:latin typeface="Arial" pitchFamily="34" charset="0"/>
+                <a:ea typeface="Arial" pitchFamily="34" charset="-122"/>
+                <a:cs typeface="Arial" pitchFamily="34" charset="-120"/>
+              </a:rPr>
+              <a:t>event_waitlist</a:t>
+            </a:r>
+            <a:endParaRPr lang="en-US" sz="1050" dirty="0"/>
+          </a:p>
+          <a:p>
+            <a:pPr indent="0" marL="0">
+              <a:spcAft>
+                <a:spcPts val="300"/>
+              </a:spcAft>
+              <a:buNone/>
+            </a:pPr>
+            <a:r>
+              <a:rPr lang="en-US" sz="1050" dirty="0">
+                <a:solidFill>
+                  <a:srgbClr val="44403C"/>
+                </a:solidFill>
+                <a:latin typeface="Arial" pitchFamily="34" charset="0"/>
+                <a:ea typeface="Arial" pitchFamily="34" charset="-122"/>
+                <a:cs typeface="Arial" pitchFamily="34" charset="-120"/>
+              </a:rPr>
+              <a:t>event_checkin_codes</a:t>
+            </a:r>
+            <a:endParaRPr lang="en-US" sz="1050" dirty="0"/>
+          </a:p>
+          <a:p>
+            <a:pPr indent="0" marL="0">
+              <a:spcAft>
+                <a:spcPts val="300"/>
+              </a:spcAft>
+              <a:buNone/>
+            </a:pPr>
+            <a:r>
+              <a:rPr lang="en-US" sz="1050" dirty="0">
+                <a:solidFill>
+                  <a:srgbClr val="44403C"/>
+                </a:solidFill>
+                <a:latin typeface="Arial" pitchFamily="34" charset="0"/>
+                <a:ea typeface="Arial" pitchFamily="34" charset="-122"/>
+                <a:cs typeface="Arial" pitchFamily="34" charset="-120"/>
+              </a:rPr>
+              <a:t>event_ratings</a:t>
             </a:r>
             <a:endParaRPr lang="en-US" sz="1050" dirty="0"/>
           </a:p>
@@ -12640,7 +12720,7 @@
                 <a:ea typeface="Arial" pitchFamily="34" charset="-122"/>
                 <a:cs typeface="Arial" pitchFamily="34" charset="-120"/>
               </a:rPr>
-              <a:t>Pesan</a:t>
+              <a:t>Grup &amp; pesan</a:t>
             </a:r>
             <a:endParaRPr lang="en-US" sz="1500" dirty="0"/>
           </a:p>
@@ -12679,7 +12759,7 @@
                 <a:ea typeface="Arial" pitchFamily="34" charset="-122"/>
                 <a:cs typeface="Arial" pitchFamily="34" charset="-120"/>
               </a:rPr>
-              <a:t>4 tabel</a:t>
+              <a:t>8 tabel</a:t>
             </a:r>
             <a:endParaRPr lang="en-US" sz="1150" dirty="0"/>
           </a:p>
@@ -12705,6 +12785,86 @@
         <p:txBody>
           <a:bodyPr wrap="square" lIns="0" tIns="0" rIns="0" bIns="0" rtlCol="0" anchor="t"/>
           <a:lstStyle/>
+          <a:p>
+            <a:pPr indent="0" marL="0">
+              <a:spcAft>
+                <a:spcPts val="300"/>
+              </a:spcAft>
+              <a:buNone/>
+            </a:pPr>
+            <a:r>
+              <a:rPr lang="en-US" sz="1050" dirty="0">
+                <a:solidFill>
+                  <a:srgbClr val="44403C"/>
+                </a:solidFill>
+                <a:latin typeface="Arial" pitchFamily="34" charset="0"/>
+                <a:ea typeface="Arial" pitchFamily="34" charset="-122"/>
+                <a:cs typeface="Arial" pitchFamily="34" charset="-120"/>
+              </a:rPr>
+              <a:t>groups</a:t>
+            </a:r>
+            <a:endParaRPr lang="en-US" sz="1050" dirty="0"/>
+          </a:p>
+          <a:p>
+            <a:pPr indent="0" marL="0">
+              <a:spcAft>
+                <a:spcPts val="300"/>
+              </a:spcAft>
+              <a:buNone/>
+            </a:pPr>
+            <a:r>
+              <a:rPr lang="en-US" sz="1050" dirty="0">
+                <a:solidFill>
+                  <a:srgbClr val="44403C"/>
+                </a:solidFill>
+                <a:latin typeface="Arial" pitchFamily="34" charset="0"/>
+                <a:ea typeface="Arial" pitchFamily="34" charset="-122"/>
+                <a:cs typeface="Arial" pitchFamily="34" charset="-120"/>
+              </a:rPr>
+              <a:t>group_members</a:t>
+            </a:r>
+            <a:endParaRPr lang="en-US" sz="1050" dirty="0"/>
+          </a:p>
+          <a:p>
+            <a:pPr indent="0" marL="0">
+              <a:spcAft>
+                <a:spcPts val="300"/>
+              </a:spcAft>
+              <a:buNone/>
+            </a:pPr>
+            <a:r>
+              <a:rPr lang="en-US" sz="1050" dirty="0">
+                <a:solidFill>
+                  <a:srgbClr val="44403C"/>
+                </a:solidFill>
+                <a:latin typeface="Arial" pitchFamily="34" charset="0"/>
+                <a:ea typeface="Arial" pitchFamily="34" charset="-122"/>
+                <a:cs typeface="Arial" pitchFamily="34" charset="-120"/>
+              </a:rPr>
+              <a:t>play_requests</a:t>
+            </a:r>
+            <a:endParaRPr lang="en-US" sz="1050" dirty="0"/>
+          </a:p>
+          <a:p>
+            <a:pPr indent="0" marL="0">
+              <a:spcAft>
+                <a:spcPts val="300"/>
+              </a:spcAft>
+              <a:buNone/>
+            </a:pPr>
+            <a:r>
+              <a:rPr lang="en-US" sz="1050" dirty="0">
+                <a:solidFill>
+                  <a:srgbClr val="44403C"/>
+                </a:solidFill>
+                <a:latin typeface="Arial" pitchFamily="34" charset="0"/>
+                <a:ea typeface="Arial" pitchFamily="34" charset="-122"/>
+                <a:cs typeface="Arial" pitchFamily="34" charset="-120"/>
+              </a:rPr>
+              <a:t>play_request_interests</a:t>
+            </a:r>
+            <a:endParaRPr lang="en-US" sz="1050" dirty="0"/>
+          </a:p>
           <a:p>
             <a:pPr indent="0" marL="0">
               <a:spcAft>
@@ -12939,7 +13099,7 @@
                 <a:ea typeface="Arial" pitchFamily="34" charset="-122"/>
                 <a:cs typeface="Arial" pitchFamily="34" charset="-120"/>
               </a:rPr>
-              <a:t>6 tabel</a:t>
+              <a:t>8 tabel</a:t>
             </a:r>
             <a:endParaRPr lang="en-US" sz="1150" dirty="0"/>
           </a:p>
@@ -13082,6 +13242,46 @@
                 <a:cs typeface="Arial" pitchFamily="34" charset="-120"/>
               </a:rPr>
               <a:t>notification_prefs</a:t>
+            </a:r>
+            <a:endParaRPr lang="en-US" sz="1050" dirty="0"/>
+          </a:p>
+          <a:p>
+            <a:pPr indent="0" marL="0">
+              <a:spcAft>
+                <a:spcPts val="300"/>
+              </a:spcAft>
+              <a:buNone/>
+            </a:pPr>
+            <a:r>
+              <a:rPr lang="en-US" sz="1050" dirty="0">
+                <a:solidFill>
+                  <a:srgbClr val="44403C"/>
+                </a:solidFill>
+                <a:latin typeface="Arial" pitchFamily="34" charset="0"/>
+                <a:ea typeface="Arial" pitchFamily="34" charset="-122"/>
+                <a:cs typeface="Arial" pitchFamily="34" charset="-120"/>
+              </a:rPr>
+              <a:t>push_subscriptions</a:t>
+            </a:r>
+            <a:endParaRPr lang="en-US" sz="1050" dirty="0"/>
+          </a:p>
+          <a:p>
+            <a:pPr indent="0" marL="0">
+              <a:spcAft>
+                <a:spcPts val="300"/>
+              </a:spcAft>
+              <a:buNone/>
+            </a:pPr>
+            <a:r>
+              <a:rPr lang="en-US" sz="1050" dirty="0">
+                <a:solidFill>
+                  <a:srgbClr val="44403C"/>
+                </a:solidFill>
+                <a:latin typeface="Arial" pitchFamily="34" charset="0"/>
+                <a:ea typeface="Arial" pitchFamily="34" charset="-122"/>
+                <a:cs typeface="Arial" pitchFamily="34" charset="-120"/>
+              </a:rPr>
+              <a:t>calendar_tokens</a:t>
             </a:r>
             <a:endParaRPr lang="en-US" sz="1050" dirty="0"/>
           </a:p>
@@ -13717,7 +13917,7 @@
                 <a:ea typeface="Arial" pitchFamily="34" charset="-122"/>
                 <a:cs typeface="Arial" pitchFamily="34" charset="-120"/>
               </a:rPr>
-              <a:t>Ke-31 tabel memakai RLS. 150+ fungsi SQL mengecek peran sebelum bertindak.</a:t>
+              <a:t>Ke-41 tabel memakai RLS. 190+ fungsi SQL mengecek peran sebelum bertindak.</a:t>
             </a:r>
             <a:endParaRPr lang="en-US" sz="1300" dirty="0"/>
           </a:p>
@@ -15745,7 +15945,7 @@
                 <a:ea typeface="Arial" pitchFamily="34" charset="-122"/>
                 <a:cs typeface="Arial" pitchFamily="34" charset="-120"/>
               </a:rPr>
-              <a:t>45</a:t>
+              <a:t>52</a:t>
             </a:r>
             <a:endParaRPr lang="en-US" sz="4400" dirty="0"/>
           </a:p>
@@ -15823,7 +16023,7 @@
                 <a:ea typeface="Arial" pitchFamily="34" charset="-122"/>
                 <a:cs typeface="Arial" pitchFamily="34" charset="-120"/>
               </a:rPr>
-              <a:t>Aplikasi anggota, area admin, dan alur masuk</a:t>
+              <a:t>Aplikasi anggota, admin, dan masuk</a:t>
             </a:r>
             <a:endParaRPr lang="en-US" sz="1250" dirty="0"/>
           </a:p>
@@ -15896,7 +16096,7 @@
                 <a:ea typeface="Arial" pitchFamily="34" charset="-122"/>
                 <a:cs typeface="Arial" pitchFamily="34" charset="-120"/>
               </a:rPr>
-              <a:t>51</a:t>
+              <a:t>74</a:t>
             </a:r>
             <a:endParaRPr lang="en-US" sz="4400" dirty="0"/>
           </a:p>
@@ -16047,7 +16247,7 @@
                 <a:ea typeface="Arial" pitchFamily="34" charset="-122"/>
                 <a:cs typeface="Arial" pitchFamily="34" charset="-120"/>
               </a:rPr>
-              <a:t>19,4 rb</a:t>
+              <a:t>25,6 rb</a:t>
             </a:r>
             <a:endParaRPr lang="en-US" sz="4400" dirty="0"/>
           </a:p>
@@ -16125,7 +16325,7 @@
                 <a:ea typeface="Arial" pitchFamily="34" charset="-122"/>
                 <a:cs typeface="Arial" pitchFamily="34" charset="-120"/>
               </a:rPr>
-              <a:t>Di 140 file sumber</a:t>
+              <a:t>Di 194 file sumber, 43 unit test</a:t>
             </a:r>
             <a:endParaRPr lang="en-US" sz="1250" dirty="0"/>
           </a:p>
@@ -16198,7 +16398,7 @@
                 <a:ea typeface="Arial" pitchFamily="34" charset="-122"/>
                 <a:cs typeface="Arial" pitchFamily="34" charset="-120"/>
               </a:rPr>
-              <a:t>4,6 rb</a:t>
+              <a:t>5,9 rb</a:t>
             </a:r>
             <a:endParaRPr lang="en-US" sz="4400" dirty="0"/>
           </a:p>
@@ -16276,7 +16476,7 @@
                 <a:ea typeface="Arial" pitchFamily="34" charset="-122"/>
                 <a:cs typeface="Arial" pitchFamily="34" charset="-120"/>
               </a:rPr>
-              <a:t>Skema plus 9 migrasi</a:t>
+              <a:t>Skema plus 26 migrasi</a:t>
             </a:r>
             <a:endParaRPr lang="en-US" sz="1250" dirty="0"/>
           </a:p>
@@ -16349,7 +16549,7 @@
                 <a:ea typeface="Arial" pitchFamily="34" charset="-122"/>
                 <a:cs typeface="Arial" pitchFamily="34" charset="-120"/>
               </a:rPr>
-              <a:t>31</a:t>
+              <a:t>41</a:t>
             </a:r>
             <a:endParaRPr lang="en-US" sz="4400" dirty="0"/>
           </a:p>
@@ -16500,7 +16700,7 @@
                 <a:ea typeface="Arial" pitchFamily="34" charset="-122"/>
                 <a:cs typeface="Arial" pitchFamily="34" charset="-120"/>
               </a:rPr>
-              <a:t>1.400+</a:t>
+              <a:t>1.700+</a:t>
             </a:r>
             <a:endParaRPr lang="en-US" sz="4400" dirty="0"/>
           </a:p>
@@ -16688,7 +16888,7 @@
                 <a:ea typeface="Arial" pitchFamily="34" charset="-122"/>
                 <a:cs typeface="Arial" pitchFamily="34" charset="-120"/>
               </a:rPr>
-              <a:t>Pembaruan terbaru, sudah tayang</a:t>
+              <a:t>Fitur terbaru</a:t>
             </a:r>
             <a:endParaRPr lang="en-US" sz="3400" dirty="0"/>
           </a:p>
@@ -16909,7 +17109,7 @@
                 <a:ea typeface="Arial" pitchFamily="34" charset="-122"/>
                 <a:cs typeface="Arial" pitchFamily="34" charset="-120"/>
               </a:rPr>
-              <a:t>Banner selalu pas</a:t>
+              <a:t>Daftar tunggu &amp; peringatan</a:t>
             </a:r>
             <a:endParaRPr lang="en-US" sz="1550" dirty="0"/>
           </a:p>
@@ -16948,7 +17148,7 @@
                 <a:ea typeface="Arial" pitchFamily="34" charset="-122"/>
                 <a:cs typeface="Arial" pitchFamily="34" charset="-120"/>
               </a:rPr>
-              <a:t>Banner berbentuk apa pun kini tampil utuh di atas latar buram yang lembut, tidak terpotong lagi.</a:t>
+              <a:t>Aktivitas penuh punya daftar tunggu yang maju sendiri. Peringatan untuk aktivitas baru sesuai hobi dan grupmu.</a:t>
             </a:r>
             <a:endParaRPr lang="en-US" sz="1200" dirty="0"/>
           </a:p>
@@ -17067,7 +17267,7 @@
                 <a:ea typeface="Arial" pitchFamily="34" charset="-122"/>
                 <a:cs typeface="Arial" pitchFamily="34" charset="-120"/>
               </a:rPr>
-              <a:t>Pembuat flyer</a:t>
+              <a:t>Check-in &amp; penilaian</a:t>
             </a:r>
             <a:endParaRPr lang="en-US" sz="1550" dirty="0"/>
           </a:p>
@@ -17106,7 +17306,7 @@
                 <a:ea typeface="Arial" pitchFamily="34" charset="-122"/>
                 <a:cs typeface="Arial" pitchFamily="34" charset="-120"/>
               </a:rPr>
-              <a:t>Penyelenggara dan admin membuat flyer 9:16, 1:1, atau 16:9 dengan kode QR, lalu unduh PNG/JPG atau bagikan.</a:t>
+              <a:t>Penyelenggara menampilkan kode QR di lokasi; yang datang menilai aktivitasnya, membentuk skor penyelenggara.</a:t>
             </a:r>
             <a:endParaRPr lang="en-US" sz="1200" dirty="0"/>
           </a:p>
@@ -17225,7 +17425,7 @@
                 <a:ea typeface="Arial" pitchFamily="34" charset="-122"/>
                 <a:cs typeface="Arial" pitchFamily="34" charset="-120"/>
               </a:rPr>
-              <a:t>Pembuatan aktivitas diperbaiki</a:t>
+              <a:t>Pengingat &amp; push</a:t>
             </a:r>
             <a:endParaRPr lang="en-US" sz="1550" dirty="0"/>
           </a:p>
@@ -17264,7 +17464,7 @@
                 <a:ea typeface="Arial" pitchFamily="34" charset="-122"/>
                 <a:cs typeface="Arial" pitchFamily="34" charset="-120"/>
               </a:rPr>
-              <a:t>Perbaikan database (migrasi 010) membuat kode aktivitas seperti COM-JAT-3962 kembali terbuat dengan lancar.</a:t>
+              <a:t>Pengingat sehari sebelumnya dan pertanyaan "Bagaimana acaranya?" sesudahnya, lewat email dan notifikasi ponsel.</a:t>
             </a:r>
             <a:endParaRPr lang="en-US" sz="1200" dirty="0"/>
           </a:p>
@@ -17383,7 +17583,7 @@
                 <a:ea typeface="Arial" pitchFamily="34" charset="-122"/>
                 <a:cs typeface="Arial" pitchFamily="34" charset="-120"/>
               </a:rPr>
-              <a:t>Peningkatan keamanan</a:t>
+              <a:t>Alat penyelenggara</a:t>
             </a:r>
             <a:endParaRPr lang="en-US" sz="1550" dirty="0"/>
           </a:p>
@@ -17422,7 +17622,7 @@
                 <a:ea typeface="Arial" pitchFamily="34" charset="-122"/>
                 <a:cs typeface="Arial" pitchFamily="34" charset="-120"/>
               </a:rPr>
-              <a:t>Next.js 16.3.6 dengan perbaikan keamanannya, dan pengecekan kode kembali aktif dengan 0 error.</a:t>
+              <a:t>Duplikat, ubah seri mingguan sekaligus, ekspor CSV, QR layar besar, teman yang ikut, dan feed kalender.</a:t>
             </a:r>
             <a:endParaRPr lang="en-US" sz="1200" dirty="0"/>
           </a:p>
@@ -18072,7 +18272,7 @@
                 <a:ea typeface="Arial" pitchFamily="34" charset="-122"/>
                 <a:cs typeface="Arial" pitchFamily="34" charset="-120"/>
               </a:rPr>
-              <a:t>Email admin mingguan dan bulanan butuh penjadwal dan kunci server.</a:t>
+              <a:t>Penjadwal sudah menjalankan pengingat; email admin mingguan bisa dibangun di atasnya.</a:t>
             </a:r>
             <a:endParaRPr lang="en-US" sz="1250" dirty="0"/>
           </a:p>
@@ -18184,7 +18384,7 @@
                 <a:ea typeface="Arial" pitchFamily="34" charset="-122"/>
                 <a:cs typeface="Arial" pitchFamily="34" charset="-120"/>
               </a:rPr>
-              <a:t>Privasi kontak</a:t>
+              <a:t>Pembayaran</a:t>
             </a:r>
             <a:endParaRPr lang="en-US" sz="1600" dirty="0"/>
           </a:p>
@@ -18223,7 +18423,7 @@
                 <a:ea typeface="Arial" pitchFamily="34" charset="-122"/>
                 <a:cs typeface="Arial" pitchFamily="34" charset="-120"/>
               </a:rPr>
-              <a:t>Sembunyikan WhatsApp penyelenggara di level database, bukan hanya di tampilan.</a:t>
+              <a:t>Aktivitas berbayar saat ini dibayar di luar aplikasi; pembayaran di aplikasi menyusul.</a:t>
             </a:r>
             <a:endParaRPr lang="en-US" sz="1250" dirty="0"/>
           </a:p>
@@ -18637,7 +18837,7 @@
                 <a:ea typeface="Arial" pitchFamily="34" charset="-122"/>
                 <a:cs typeface="Arial" pitchFamily="34" charset="-120"/>
               </a:rPr>
-              <a:t>Rapikan kode</a:t>
+              <a:t>Chat grup &amp; foto</a:t>
             </a:r>
             <a:endParaRPr lang="en-US" sz="1600" dirty="0"/>
           </a:p>
@@ -18676,7 +18876,7 @@
                 <a:ea typeface="Arial" pitchFamily="34" charset="-122"/>
                 <a:cs typeface="Arial" pitchFamily="34" charset="-120"/>
               </a:rPr>
-              <a:t>Bereskan 24 peringatan lint yang tersisa secara bertahap.</a:t>
+              <a:t>Chat per aktivitas dan album foto bersama setelahnya.</a:t>
             </a:r>
             <a:endParaRPr lang="en-US" sz="1250" dirty="0"/>
           </a:p>

</xml_diff>